<commit_message>
style(presentacion): imágenes de captura más grandes + alineadas al top
Los slides de captura tenían dos problemas detectados al revisar:
- El slide 12 (login, imagen cuadrada) llenaba el área OK, pero las
  demás (panel admin vertical, mapa horizontal, delegados vertical)
  quedaban chicas y centradas verticalmente — efecto "flotando en
  el medio del slide" que rompía la alineación con el título.

Fix:
- Área de imagen pasa de 6.0×6.5 a 6.5×7.0 (más ancho + casi toda
  la altura del slide, solo dejando footer).
- Imagen alineada AL TOP del área (no centrada vertical) →
  todas las capturas arrancan en y=0.4, al mismo nivel que el
  eyebrow + título del lado derecho.

Resultado por tipo de captura:
- Mobile vertical (740x1600): 3.22w × 7.00h — alta y angosta
- Cuadrada (login 564x601): 6.50w × 6.92h — casi llena el área
- Horizontal (mapa 837x554): 6.50w × 4.30h — llena el ancho

Co-Authored-By: Claude Opus 4.7 (1M context) <noreply@anthropic.com>
</commit_message>
<xml_diff>
--- a/Presentacion-APOPS-Siempre.pptx
+++ b/Presentacion-APOPS-Siempre.pptx
@@ -4956,12 +4956,12 @@
         </p:nvSpPr>
         <p:spPr>
           <a:xfrm>
-            <a:off x="420624" y="487550"/>
-            <a:ext cx="5486400" cy="5846323"/>
+            <a:off x="420624" y="438912"/>
+            <a:ext cx="5943600" cy="6333517"/>
           </a:xfrm>
           <a:prstGeom prst="roundRect">
             <a:avLst>
-              <a:gd name="adj" fmla="val 2000"/>
+              <a:gd name="adj" fmla="val 1846"/>
             </a:avLst>
           </a:prstGeom>
           <a:solidFill>
@@ -4988,8 +4988,8 @@
         </p:blipFill>
         <p:spPr>
           <a:xfrm>
-            <a:off x="365760" y="414398"/>
-            <a:ext cx="5486400" cy="5846323"/>
+            <a:off x="365760" y="365760"/>
+            <a:ext cx="5943600" cy="6333517"/>
           </a:xfrm>
           <a:prstGeom prst="rect">
             <a:avLst/>
@@ -5381,12 +5381,12 @@
         </p:nvSpPr>
         <p:spPr>
           <a:xfrm>
-            <a:off x="1789367" y="438912"/>
-            <a:ext cx="2748915" cy="5943600"/>
+            <a:off x="1912239" y="438912"/>
+            <a:ext cx="2960370" cy="6400800"/>
           </a:xfrm>
           <a:prstGeom prst="roundRect">
             <a:avLst>
-              <a:gd name="adj" fmla="val 3992"/>
+              <a:gd name="adj" fmla="val 3707"/>
             </a:avLst>
           </a:prstGeom>
           <a:solidFill>
@@ -5413,8 +5413,8 @@
         </p:blipFill>
         <p:spPr>
           <a:xfrm>
-            <a:off x="1734503" y="365760"/>
-            <a:ext cx="2748915" cy="5943600"/>
+            <a:off x="1857375" y="365760"/>
+            <a:ext cx="2960370" cy="6400800"/>
           </a:xfrm>
           <a:prstGeom prst="rect">
             <a:avLst/>
@@ -5806,12 +5806,12 @@
         </p:nvSpPr>
         <p:spPr>
           <a:xfrm>
-            <a:off x="909722" y="438912"/>
-            <a:ext cx="4508205" cy="5943600"/>
+            <a:off x="964929" y="438912"/>
+            <a:ext cx="4854990" cy="6400800"/>
           </a:xfrm>
           <a:prstGeom prst="roundRect">
             <a:avLst>
-              <a:gd name="adj" fmla="val 2434"/>
+              <a:gd name="adj" fmla="val 2260"/>
             </a:avLst>
           </a:prstGeom>
           <a:solidFill>
@@ -5838,8 +5838,8 @@
         </p:blipFill>
         <p:spPr>
           <a:xfrm>
-            <a:off x="854858" y="365760"/>
-            <a:ext cx="4508205" cy="5943600"/>
+            <a:off x="910065" y="365760"/>
+            <a:ext cx="4854990" cy="6400800"/>
           </a:xfrm>
           <a:prstGeom prst="rect">
             <a:avLst/>
@@ -6231,12 +6231,12 @@
         </p:nvSpPr>
         <p:spPr>
           <a:xfrm>
-            <a:off x="420624" y="1595022"/>
-            <a:ext cx="5486400" cy="3631381"/>
+            <a:off x="420624" y="438912"/>
+            <a:ext cx="5943600" cy="3933996"/>
           </a:xfrm>
           <a:prstGeom prst="roundRect">
             <a:avLst>
-              <a:gd name="adj" fmla="val 3022"/>
+              <a:gd name="adj" fmla="val 2789"/>
             </a:avLst>
           </a:prstGeom>
           <a:solidFill>
@@ -6263,8 +6263,8 @@
         </p:blipFill>
         <p:spPr>
           <a:xfrm>
-            <a:off x="365760" y="1521870"/>
-            <a:ext cx="5486400" cy="3631381"/>
+            <a:off x="365760" y="365760"/>
+            <a:ext cx="5943600" cy="3933996"/>
           </a:xfrm>
           <a:prstGeom prst="rect">
             <a:avLst/>
@@ -6656,12 +6656,12 @@
         </p:nvSpPr>
         <p:spPr>
           <a:xfrm>
-            <a:off x="1789367" y="438912"/>
-            <a:ext cx="2748915" cy="5943600"/>
+            <a:off x="1912239" y="438912"/>
+            <a:ext cx="2960370" cy="6400800"/>
           </a:xfrm>
           <a:prstGeom prst="roundRect">
             <a:avLst>
-              <a:gd name="adj" fmla="val 3992"/>
+              <a:gd name="adj" fmla="val 3707"/>
             </a:avLst>
           </a:prstGeom>
           <a:solidFill>
@@ -6688,8 +6688,8 @@
         </p:blipFill>
         <p:spPr>
           <a:xfrm>
-            <a:off x="1734503" y="365760"/>
-            <a:ext cx="2748915" cy="5943600"/>
+            <a:off x="1857375" y="365760"/>
+            <a:ext cx="2960370" cy="6400800"/>
           </a:xfrm>
           <a:prstGeom prst="rect">
             <a:avLst/>
@@ -7081,12 +7081,12 @@
         </p:nvSpPr>
         <p:spPr>
           <a:xfrm>
-            <a:off x="1789367" y="438912"/>
-            <a:ext cx="2748915" cy="5943600"/>
+            <a:off x="1912239" y="438912"/>
+            <a:ext cx="2960370" cy="6400800"/>
           </a:xfrm>
           <a:prstGeom prst="roundRect">
             <a:avLst>
-              <a:gd name="adj" fmla="val 3992"/>
+              <a:gd name="adj" fmla="val 3707"/>
             </a:avLst>
           </a:prstGeom>
           <a:solidFill>
@@ -7113,8 +7113,8 @@
         </p:blipFill>
         <p:spPr>
           <a:xfrm>
-            <a:off x="1734503" y="365760"/>
-            <a:ext cx="2748915" cy="5943600"/>
+            <a:off x="1857375" y="365760"/>
+            <a:ext cx="2960370" cy="6400800"/>
           </a:xfrm>
           <a:prstGeom prst="rect">
             <a:avLst/>
@@ -7506,12 +7506,12 @@
         </p:nvSpPr>
         <p:spPr>
           <a:xfrm>
-            <a:off x="420624" y="1485106"/>
-            <a:ext cx="5486400" cy="3851213"/>
+            <a:off x="420624" y="438912"/>
+            <a:ext cx="5943600" cy="4172147"/>
           </a:xfrm>
           <a:prstGeom prst="roundRect">
             <a:avLst>
-              <a:gd name="adj" fmla="val 2849"/>
+              <a:gd name="adj" fmla="val 2630"/>
             </a:avLst>
           </a:prstGeom>
           <a:solidFill>
@@ -7538,8 +7538,8 @@
         </p:blipFill>
         <p:spPr>
           <a:xfrm>
-            <a:off x="365760" y="1411954"/>
-            <a:ext cx="5486400" cy="3851213"/>
+            <a:off x="365760" y="365760"/>
+            <a:ext cx="5943600" cy="4172147"/>
           </a:xfrm>
           <a:prstGeom prst="rect">
             <a:avLst/>

</xml_diff>

<commit_message>
style(presentacion): área de captura más moderada (5.8x6) para no invadir footer
El cambio anterior (área 6.5x7, top-aligned) corrigió la alineación
pero hizo que las capturas mobile verticales quedaran gigantes,
invadiendo el footer del slide. El login también quedó demasiado
grande.

Fix: bajar área a 5.8w × 6.0h desde x=0.5, y=0.55. Mantiene la
alineación al top de todas las imágenes (al mismo nivel del título
derecho) pero sin invadir el footer:

- Mobile vertical (740x1600): 2.76 × 6.00 (antes 3.22 × 7.00)
- Cuadrada login (564x601): 5.62 × 6.00 (antes 6.50 × 6.92)
- Horizontal mapa (837x554): 5.80 × 3.84 (antes 6.50 × 4.30)

Footer ahora respira (margen de 1.1" hasta H=7.5).

Co-Authored-By: Claude Opus 4.7 (1M context) <noreply@anthropic.com>
</commit_message>
<xml_diff>
--- a/Presentacion-APOPS-Siempre.pptx
+++ b/Presentacion-APOPS-Siempre.pptx
@@ -4956,12 +4956,12 @@
         </p:nvSpPr>
         <p:spPr>
           <a:xfrm>
-            <a:off x="420624" y="438912"/>
-            <a:ext cx="5943600" cy="6333517"/>
+            <a:off x="589507" y="576072"/>
+            <a:ext cx="5148635" cy="5486400"/>
           </a:xfrm>
           <a:prstGeom prst="roundRect">
             <a:avLst>
-              <a:gd name="adj" fmla="val 1846"/>
+              <a:gd name="adj" fmla="val 2131"/>
             </a:avLst>
           </a:prstGeom>
           <a:solidFill>
@@ -4988,8 +4988,8 @@
         </p:blipFill>
         <p:spPr>
           <a:xfrm>
-            <a:off x="365760" y="365760"/>
-            <a:ext cx="5943600" cy="6333517"/>
+            <a:off x="534643" y="502920"/>
+            <a:ext cx="5148635" cy="5486400"/>
           </a:xfrm>
           <a:prstGeom prst="rect">
             <a:avLst/>
@@ -5381,12 +5381,12 @@
         </p:nvSpPr>
         <p:spPr>
           <a:xfrm>
-            <a:off x="1912239" y="438912"/>
-            <a:ext cx="2960370" cy="6400800"/>
+            <a:off x="1895094" y="576072"/>
+            <a:ext cx="2537460" cy="5486400"/>
           </a:xfrm>
           <a:prstGeom prst="roundRect">
             <a:avLst>
-              <a:gd name="adj" fmla="val 3707"/>
+              <a:gd name="adj" fmla="val 4324"/>
             </a:avLst>
           </a:prstGeom>
           <a:solidFill>
@@ -5413,8 +5413,8 @@
         </p:blipFill>
         <p:spPr>
           <a:xfrm>
-            <a:off x="1857375" y="365760"/>
-            <a:ext cx="2960370" cy="6400800"/>
+            <a:off x="1840230" y="502920"/>
+            <a:ext cx="2537460" cy="5486400"/>
           </a:xfrm>
           <a:prstGeom prst="rect">
             <a:avLst/>
@@ -5806,12 +5806,12 @@
         </p:nvSpPr>
         <p:spPr>
           <a:xfrm>
-            <a:off x="964929" y="438912"/>
-            <a:ext cx="4854990" cy="6400800"/>
+            <a:off x="1083114" y="576072"/>
+            <a:ext cx="4161420" cy="5486400"/>
           </a:xfrm>
           <a:prstGeom prst="roundRect">
             <a:avLst>
-              <a:gd name="adj" fmla="val 2260"/>
+              <a:gd name="adj" fmla="val 2637"/>
             </a:avLst>
           </a:prstGeom>
           <a:solidFill>
@@ -5838,8 +5838,8 @@
         </p:blipFill>
         <p:spPr>
           <a:xfrm>
-            <a:off x="910065" y="365760"/>
-            <a:ext cx="4854990" cy="6400800"/>
+            <a:off x="1028250" y="502920"/>
+            <a:ext cx="4161420" cy="5486400"/>
           </a:xfrm>
           <a:prstGeom prst="rect">
             <a:avLst/>
@@ -6231,12 +6231,12 @@
         </p:nvSpPr>
         <p:spPr>
           <a:xfrm>
-            <a:off x="420624" y="438912"/>
-            <a:ext cx="5943600" cy="3933996"/>
+            <a:off x="512064" y="576072"/>
+            <a:ext cx="5303520" cy="3510335"/>
           </a:xfrm>
           <a:prstGeom prst="roundRect">
             <a:avLst>
-              <a:gd name="adj" fmla="val 2789"/>
+              <a:gd name="adj" fmla="val 3126"/>
             </a:avLst>
           </a:prstGeom>
           <a:solidFill>
@@ -6263,8 +6263,8 @@
         </p:blipFill>
         <p:spPr>
           <a:xfrm>
-            <a:off x="365760" y="365760"/>
-            <a:ext cx="5943600" cy="3933996"/>
+            <a:off x="457200" y="502920"/>
+            <a:ext cx="5303520" cy="3510335"/>
           </a:xfrm>
           <a:prstGeom prst="rect">
             <a:avLst/>
@@ -6656,12 +6656,12 @@
         </p:nvSpPr>
         <p:spPr>
           <a:xfrm>
-            <a:off x="1912239" y="438912"/>
-            <a:ext cx="2960370" cy="6400800"/>
+            <a:off x="1895094" y="576072"/>
+            <a:ext cx="2537460" cy="5486400"/>
           </a:xfrm>
           <a:prstGeom prst="roundRect">
             <a:avLst>
-              <a:gd name="adj" fmla="val 3707"/>
+              <a:gd name="adj" fmla="val 4324"/>
             </a:avLst>
           </a:prstGeom>
           <a:solidFill>
@@ -6688,8 +6688,8 @@
         </p:blipFill>
         <p:spPr>
           <a:xfrm>
-            <a:off x="1857375" y="365760"/>
-            <a:ext cx="2960370" cy="6400800"/>
+            <a:off x="1840230" y="502920"/>
+            <a:ext cx="2537460" cy="5486400"/>
           </a:xfrm>
           <a:prstGeom prst="rect">
             <a:avLst/>
@@ -7081,12 +7081,12 @@
         </p:nvSpPr>
         <p:spPr>
           <a:xfrm>
-            <a:off x="1912239" y="438912"/>
-            <a:ext cx="2960370" cy="6400800"/>
+            <a:off x="1895094" y="576072"/>
+            <a:ext cx="2537460" cy="5486400"/>
           </a:xfrm>
           <a:prstGeom prst="roundRect">
             <a:avLst>
-              <a:gd name="adj" fmla="val 3707"/>
+              <a:gd name="adj" fmla="val 4324"/>
             </a:avLst>
           </a:prstGeom>
           <a:solidFill>
@@ -7113,8 +7113,8 @@
         </p:blipFill>
         <p:spPr>
           <a:xfrm>
-            <a:off x="1857375" y="365760"/>
-            <a:ext cx="2960370" cy="6400800"/>
+            <a:off x="1840230" y="502920"/>
+            <a:ext cx="2537460" cy="5486400"/>
           </a:xfrm>
           <a:prstGeom prst="rect">
             <a:avLst/>
@@ -7506,12 +7506,12 @@
         </p:nvSpPr>
         <p:spPr>
           <a:xfrm>
-            <a:off x="420624" y="438912"/>
-            <a:ext cx="5943600" cy="4172147"/>
+            <a:off x="512064" y="576072"/>
+            <a:ext cx="5303520" cy="3722839"/>
           </a:xfrm>
           <a:prstGeom prst="roundRect">
             <a:avLst>
-              <a:gd name="adj" fmla="val 2630"/>
+              <a:gd name="adj" fmla="val 2947"/>
             </a:avLst>
           </a:prstGeom>
           <a:solidFill>
@@ -7538,8 +7538,8 @@
         </p:blipFill>
         <p:spPr>
           <a:xfrm>
-            <a:off x="365760" y="365760"/>
-            <a:ext cx="5943600" cy="4172147"/>
+            <a:off x="457200" y="502920"/>
+            <a:ext cx="5303520" cy="3722839"/>
           </a:xfrm>
           <a:prstGeom prst="rect">
             <a:avLst/>

</xml_diff>